<commit_message>
Slides builder: public image URLs, image-free default fills, and live-run fixes
Keep explicit public image URLs and drop GitHub raw URLs only when an
unauthenticated fetch says the repo is private. Ignore placeholder IDs so
default fills never ship broken createImage requests. Skip the smile unless
--place-smile, since the imported layouts already carry it. Bold the cover
title, add bullet spacing and a smaller glyph, draw a chart axis with ticks
and gridlines, and move the section footer clear of the rail in both
builders and the template. Add check_outline.py and unit tests.

Co-authored-by: Audge <audr3x@users.noreply.github.com>
</commit_message>
<xml_diff>
--- a/docs/proof/planning-workshop.pptx
+++ b/docs/proof/planning-workshop.pptx
@@ -1866,7 +1866,7 @@
         </p:nvSpPr>
         <p:spPr>
           <a:xfrm>
-            <a:off x="27432" y="4818888"/>
+            <a:off x="3035808" y="4818888"/>
             <a:ext cx="3086100" cy="274637"/>
           </a:xfrm>
           <a:prstGeom prst="rect">
@@ -7144,7 +7144,7 @@
         </p:nvSpPr>
         <p:spPr>
           <a:xfrm>
-            <a:off x="457200" y="4818888"/>
+            <a:off x="3035808" y="4818888"/>
             <a:ext cx="3086100" cy="274320"/>
           </a:xfrm>
           <a:prstGeom prst="rect">

</xml_diff>

<commit_message>
Chart legend below the plot, not over the bars; count 'everything is included' as a completeness claim
Co-authored-by: Audge <audr3x@users.noreply.github.com>
</commit_message>
<xml_diff>
--- a/docs/proof/planning-workshop.pptx
+++ b/docs/proof/planning-workshop.pptx
@@ -451,7 +451,7 @@
         <c:axPos val="b"/>
         <c:majorTickMark val="out"/>
         <c:minorTickMark val="none"/>
-        <c:tickLblPos val="nextTo"/>
+        <c:tickLblPos val="low"/>
         <c:spPr>
           <a:ln>
             <a:solidFill>
@@ -523,8 +523,8 @@
       </c:valAx>
     </c:plotArea>
     <c:legend>
-      <c:legendPos/>
-      <c:overlay val="1"/>
+      <c:legendPos val="b"/>
+      <c:overlay val="0"/>
       <c:txPr>
         <a:bodyPr/>
         <a:lstStyle/>

</xml_diff>